<commit_message>
Add proposal PPTX: NK Law Office (June 5, 2026)
Co-Authored-By: Claude Sonnet 4.6 <noreply@anthropic.com>
</commit_message>
<xml_diff>
--- a/nk-law-office/NK_Law_Office_June_5_2026_Proposal.pptx
+++ b/nk-law-office/NK_Law_Office_June_5_2026_Proposal.pptx
@@ -3730,7 +3730,7 @@
                 </a:solidFill>
                 <a:latin typeface="Calibri"/>
               </a:rPr>
-              <a:t>Solo intake, no process</a:t>
+              <a:t>All intake handled solo</a:t>
             </a:r>
           </a:p>
         </p:txBody>
@@ -3919,7 +3919,7 @@
                 </a:solidFill>
                 <a:latin typeface="Calibri"/>
               </a:rPr>
-              <a:t>Solo — no team</a:t>
+              <a:t>Solo — no team at all</a:t>
             </a:r>
           </a:p>
         </p:txBody>
@@ -4075,7 +4075,7 @@
                 </a:solidFill>
                 <a:latin typeface="Calibri"/>
               </a:rPr>
-              <a:t>AMBER</a:t>
+              <a:t>NEEDS WORK</a:t>
             </a:r>
           </a:p>
         </p:txBody>
@@ -4297,7 +4297,7 @@
                 </a:solidFill>
                 <a:latin typeface="Calibri"/>
               </a:rPr>
-              <a:t>Website not indexed by Google — invisible to all client searches</a:t>
+              <a:t>Website not indexed on Google — even referrals sent to the site can't find it</a:t>
             </a:r>
           </a:p>
         </p:txBody>
@@ -4453,7 +4453,7 @@
                 </a:solidFill>
                 <a:latin typeface="Calibri"/>
               </a:rPr>
-              <a:t>Solo intake: every lead waits for the attorney personally</a:t>
+              <a:t>No intake system — after-hours calls go unanswered while competitors answer</a:t>
             </a:r>
           </a:p>
         </p:txBody>
@@ -4609,7 +4609,7 @@
                 </a:solidFill>
                 <a:latin typeface="Calibri"/>
               </a:rPr>
-              <a:t>Competitor in same building has 543 reviews, outranks at this address</a:t>
+              <a:t>Same-building competitor has 543 reviews vs. near-zero for NK Law Office</a:t>
             </a:r>
           </a:p>
         </p:txBody>
@@ -4629,7 +4629,7 @@
             <a:avLst/>
           </a:prstGeom>
           <a:solidFill>
-            <a:srgbClr val="0C2818"/>
+            <a:srgbClr val="2C1010"/>
           </a:solidFill>
           <a:ln>
             <a:solidFill>
@@ -4674,7 +4674,7 @@
             <a:avLst/>
           </a:prstGeom>
           <a:solidFill>
-            <a:srgbClr val="16A34A"/>
+            <a:srgbClr val="C0392B"/>
           </a:solidFill>
           <a:ln>
             <a:solidFill>
@@ -4732,7 +4732,7 @@
                 </a:solidFill>
                 <a:latin typeface="Calibri"/>
               </a:rPr>
-              <a:t>✓</a:t>
+              <a:t>✕</a:t>
             </a:r>
           </a:p>
         </p:txBody>
@@ -4761,11 +4761,11 @@
             <a:r>
               <a:rPr sz="1000" b="0" i="0">
                 <a:solidFill>
-                  <a:srgbClr val="86EFAC"/>
-                </a:solidFill>
-                <a:latin typeface="Calibri"/>
-              </a:rPr>
-              <a:t>Professional site with LL.M credentials — strong trust signals ready</a:t>
+                  <a:srgbClr val="F0BABA"/>
+                </a:solidFill>
+                <a:latin typeface="Calibri"/>
+              </a:rPr>
+              <a:t>Zero paid ads while competitors run Google Ads, LSA, and Meta simultaneously</a:t>
             </a:r>
           </a:p>
         </p:txBody>
@@ -5110,7 +5110,7 @@
                 </a:solidFill>
                 <a:latin typeface="Calibri"/>
               </a:rPr>
-              <a:t>700+ reviews</a:t>
+              <a:t>700+ reviews · 4.9★</a:t>
             </a:r>
           </a:p>
         </p:txBody>
@@ -5143,7 +5143,7 @@
                 </a:solidFill>
                 <a:latin typeface="Calibri"/>
               </a:rPr>
-              <a:t>Ads · LSA · Facebook · all channels</a:t>
+              <a:t>Dominates criminal defense</a:t>
             </a:r>
           </a:p>
         </p:txBody>
@@ -5254,7 +5254,7 @@
                 </a:solidFill>
                 <a:latin typeface="Calibri"/>
               </a:rPr>
-              <a:t>260 reviews</a:t>
+              <a:t>260 reviews · 4.6★</a:t>
             </a:r>
           </a:p>
         </p:txBody>
@@ -5287,7 +5287,7 @@
                 </a:solidFill>
                 <a:latin typeface="Calibri"/>
               </a:rPr>
-              <a:t>Immigration + criminal + family</a:t>
+              <a:t>Crim + immigration + family</a:t>
             </a:r>
           </a:p>
         </p:txBody>
@@ -5398,7 +5398,7 @@
                 </a:solidFill>
                 <a:latin typeface="Calibri"/>
               </a:rPr>
-              <a:t>543 reviews</a:t>
+              <a:t>543 reviews · 4.9★</a:t>
             </a:r>
           </a:p>
         </p:txBody>
@@ -5431,7 +5431,7 @@
                 </a:solidFill>
                 <a:latin typeface="Calibri"/>
               </a:rPr>
-              <a:t>Same building · real estate dominant</a:t>
+              <a:t>Same building — real estate</a:t>
             </a:r>
           </a:p>
         </p:txBody>
@@ -5587,7 +5587,7 @@
                 </a:solidFill>
                 <a:latin typeface="Calibri"/>
               </a:rPr>
-              <a:t>~0 reviews</a:t>
+              <a:t>0 reviews</a:t>
             </a:r>
           </a:p>
         </p:txBody>
@@ -5884,7 +5884,7 @@
                 </a:solidFill>
                 <a:latin typeface="Calibri"/>
               </a:rPr>
-              <a:t>Your Growth Plan: 3 Priorities to Build NK Law Office</a:t>
+              <a:t>Your Growth Plan: 3 Priorities to Reach $1M</a:t>
             </a:r>
           </a:p>
         </p:txBody>
@@ -6040,7 +6040,7 @@
                 </a:solidFill>
                 <a:latin typeface="Calibri"/>
               </a:rPr>
-              <a:t>All four pillars must work together: Lead Generation, Intake, Team, and Profit. Missing any one means growth stalls regardless of how much is invested. When all four are running, Nkiru can focus on the law — and let the firm grow on its own terms.</a:t>
+              <a:t>Marketing, Intake, Team, and Profit must all work together — a gap in any one pillar caps the rest. When all four run systematically, Nkiru can focus on practicing law instead of managing everything around it.</a:t>
             </a:r>
           </a:p>
         </p:txBody>
@@ -6118,7 +6118,7 @@
                 </a:solidFill>
                 <a:latin typeface="Calibri"/>
               </a:rPr>
-              <a:t>Stage 3 → Stage 6 Law Firm Owner</a:t>
+              <a:t>$500K → $1M revenue</a:t>
             </a:r>
           </a:p>
         </p:txBody>
@@ -6151,7 +6151,7 @@
                 </a:solidFill>
                 <a:latin typeface="Calibri"/>
               </a:rPr>
-              <a:t>A firm that grows — so you can focus on the law</a:t>
+              <a:t>Build a firm that runs — and pays you for it</a:t>
             </a:r>
           </a:p>
         </p:txBody>
@@ -6418,7 +6418,7 @@
                 </a:solidFill>
                 <a:latin typeface="Calibri"/>
               </a:rPr>
-              <a:t>Get NK Law Office indexed and visible on Google</a:t>
+              <a:t>Turn Google into a client pipeline that runs 24/7</a:t>
             </a:r>
           </a:p>
         </p:txBody>
@@ -6541,7 +6541,7 @@
                 </a:solidFill>
                 <a:latin typeface="Calibri"/>
               </a:rPr>
-              <a:t>Launch Google Ads: criminal defense + immigration</a:t>
+              <a:t>Get indexed on Google — stop being invisible online</a:t>
             </a:r>
           </a:p>
         </p:txBody>
@@ -6664,7 +6664,7 @@
                 </a:solidFill>
                 <a:latin typeface="Calibri"/>
               </a:rPr>
-              <a:t>Build GBP reviews toward LSA top-of-page placement</a:t>
+              <a:t>Run Google Ads for criminal defense and immigration</a:t>
             </a:r>
           </a:p>
         </p:txBody>
@@ -6787,7 +6787,7 @@
                 </a:solidFill>
                 <a:latin typeface="Calibri"/>
               </a:rPr>
-              <a:t>List in Avvo, FindLaw, Yelp, Justia — citation base</a:t>
+              <a:t>Build GBP reviews to rank in Calgary's map pack</a:t>
             </a:r>
           </a:p>
         </p:txBody>
@@ -6910,7 +6910,7 @@
                 </a:solidFill>
                 <a:latin typeface="Calibri"/>
               </a:rPr>
-              <a:t>Turn Google into a client pipeline that runs itself</a:t>
+              <a:t>Launch directory listings — 8 citations in 90 days</a:t>
             </a:r>
           </a:p>
         </p:txBody>
@@ -7177,7 +7177,7 @@
                 </a:solidFill>
                 <a:latin typeface="Calibri"/>
               </a:rPr>
-              <a:t>Install after-hours inquiry capture system</a:t>
+              <a:t>Install after-hours capture — no missed inquiries</a:t>
             </a:r>
           </a:p>
         </p:txBody>
@@ -7300,7 +7300,7 @@
                 </a:solidFill>
                 <a:latin typeface="Calibri"/>
               </a:rPr>
-              <a:t>Add above-fold contact form to homepage</a:t>
+              <a:t>Move contact form above the fold on homepage</a:t>
             </a:r>
           </a:p>
         </p:txBody>
@@ -7423,7 +7423,7 @@
                 </a:solidFill>
                 <a:latin typeface="Calibri"/>
               </a:rPr>
-              <a:t>Build follow-up process for unconverted leads</a:t>
+              <a:t>Build a follow-up sequence that runs without you</a:t>
             </a:r>
           </a:p>
         </p:txBody>
@@ -7546,7 +7546,7 @@
                 </a:solidFill>
                 <a:latin typeface="Calibri"/>
               </a:rPr>
-              <a:t>Create intake script so calls qualify without you</a:t>
+              <a:t>Design an intake process you can hire and train into</a:t>
             </a:r>
           </a:p>
         </p:txBody>
@@ -7669,7 +7669,7 @@
                 </a:solidFill>
                 <a:latin typeface="Calibri"/>
               </a:rPr>
-              <a:t>Convert more of the traffic you're already getting</a:t>
+              <a:t>Stop leads from reaching a competitor's voicemail</a:t>
             </a:r>
           </a:p>
         </p:txBody>
@@ -7936,7 +7936,7 @@
                 </a:solidFill>
                 <a:latin typeface="Calibri"/>
               </a:rPr>
-              <a:t>Plan and hire your first intake coordinator</a:t>
+              <a:t>Hire a part-time intake coordinator — free your hours</a:t>
             </a:r>
           </a:p>
         </p:txBody>
@@ -8059,7 +8059,7 @@
                 </a:solidFill>
                 <a:latin typeface="Calibri"/>
               </a:rPr>
-              <a:t>Track revenue and time invested by practice area</a:t>
+              <a:t>Map case value by practice area — know what to grow</a:t>
             </a:r>
           </a:p>
         </p:txBody>
@@ -8182,7 +8182,7 @@
                 </a:solidFill>
                 <a:latin typeface="Calibri"/>
               </a:rPr>
-              <a:t>Set monthly profit targets — plan it, don't discover it</a:t>
+              <a:t>Track acquisition cost so ad spend is defensible</a:t>
             </a:r>
           </a:p>
         </p:txBody>
@@ -8305,7 +8305,7 @@
                 </a:solidFill>
                 <a:latin typeface="Calibri"/>
               </a:rPr>
-              <a:t>Weekly coaching for firm-building strategy and clarity</a:t>
+              <a:t>Build org structure to support a first full hire</a:t>
             </a:r>
           </a:p>
         </p:txBody>
@@ -8428,7 +8428,7 @@
                 </a:solidFill>
                 <a:latin typeface="Calibri"/>
               </a:rPr>
-              <a:t>Build systems that let you step back without worry</a:t>
+              <a:t>Plan profit intentionally — not just discover it</a:t>
             </a:r>
           </a:p>
         </p:txBody>
@@ -8992,7 +8992,7 @@
                 </a:solidFill>
                 <a:latin typeface="Calibri"/>
               </a:rPr>
-              <a:t>Website · Google Ads · LSA · Meta Ads · SEO · GBP</a:t>
+              <a:t>Website · Google Ads · LSA · Meta Ads · GBP optimization</a:t>
             </a:r>
           </a:p>
         </p:txBody>
@@ -9292,7 +9292,7 @@
                 </a:solidFill>
                 <a:latin typeface="Calibri"/>
               </a:rPr>
-              <a:t>Weekly coaching · masterminds · 1:1 strategy sessions</a:t>
+              <a:t>Weekly coaching · 1:1 sessions · Intake framework · Workshops</a:t>
             </a:r>
           </a:p>
         </p:txBody>
@@ -9736,7 +9736,7 @@
                 </a:solidFill>
                 <a:latin typeface="Calibri"/>
               </a:rPr>
-              <a:t>Conservative  (~10 cases/mo):</a:t>
+              <a:t>Conservative  (10 cases/mo):</a:t>
             </a:r>
           </a:p>
         </p:txBody>
@@ -9769,7 +9769,7 @@
                 </a:solidFill>
                 <a:latin typeface="Calibri"/>
               </a:rPr>
-              <a:t>~$40,000 revenue · 5.3× ROAS</a:t>
+              <a:t>$40,000 revenue · 5.3× ROAS</a:t>
             </a:r>
           </a:p>
         </p:txBody>
@@ -9802,7 +9802,7 @@
                 </a:solidFill>
                 <a:latin typeface="Calibri"/>
               </a:rPr>
-              <a:t>Aggressive  (~41 cases/mo):</a:t>
+              <a:t>Aggressive  (42 cases/mo):</a:t>
             </a:r>
           </a:p>
         </p:txBody>
@@ -9835,7 +9835,7 @@
                 </a:solidFill>
                 <a:latin typeface="Calibri"/>
               </a:rPr>
-              <a:t>~$164,000 revenue · 6.6× ROAS</a:t>
+              <a:t>$168,000 revenue · 6.6× ROAS</a:t>
             </a:r>
           </a:p>
         </p:txBody>
@@ -9979,7 +9979,7 @@
                 </a:solidFill>
                 <a:latin typeface="Calibri"/>
               </a:rPr>
-              <a:t>Launch Google Ads — criminal defense + immigration</a:t>
+              <a:t>Launch Google Ads — criminal defense, immigration</a:t>
             </a:r>
           </a:p>
         </p:txBody>
@@ -10090,7 +10090,7 @@
                 </a:solidFill>
                 <a:latin typeface="Calibri"/>
               </a:rPr>
-              <a:t>Website rebuild with above-fold CTAs + practice pages</a:t>
+              <a:t>Website rebuild live — indexed, above-fold CTA</a:t>
             </a:r>
           </a:p>
         </p:txBody>
@@ -10201,7 +10201,7 @@
                 </a:solidFill>
                 <a:latin typeface="Calibri"/>
               </a:rPr>
-              <a:t>Complete GBP setup and legal directory listings</a:t>
+              <a:t>GBP setup + top legal directories complete</a:t>
             </a:r>
           </a:p>
         </p:txBody>
@@ -10312,7 +10312,7 @@
                 </a:solidFill>
                 <a:latin typeface="Calibri"/>
               </a:rPr>
-              <a:t>Begin active Google review generation strategy</a:t>
+              <a:t>Google review generation campaign launched</a:t>
             </a:r>
           </a:p>
         </p:txBody>
@@ -10501,7 +10501,7 @@
                 </a:solidFill>
                 <a:latin typeface="Calibri"/>
               </a:rPr>
-              <a:t>"The clients are already searching. The expertise is already there. This is the system that makes sure they find each other."</a:t>
+              <a:t>"You built this practice from scratch. Now build the system that makes it grow without requiring your presence in every file, every call, and every decision."</a:t>
             </a:r>
           </a:p>
         </p:txBody>

</xml_diff>